<commit_message>
W01 D4 study notes with checked citations, the printed cheat sheet, solution notebooks that the verifier cold-runs, and brief paths corrected in the case notebooks and the afternoon deck
Co-Authored-By: Claude Opus 5.5 <noreply@anthropic.com>
Claude-Session: https://claude.ai/code/session_01KVVrwgNCc4sG8fTmEoH6eV
</commit_message>
<xml_diff>
--- a/content/W01/D4/slides/C2_W01_D04_half2_STUDENT.pptx
+++ b/content/W01/D4/slides/C2_W01_D04_half2_STUDENT.pptx
@@ -832,7 +832,7 @@
           <a:lstStyle/>
           <a:p>
             <a:r>
-              <a:t>LIVE. Ten-minute break before this chapter. Pairs work from exercises/unguided/C2_W01_D04_second_case_STUDENT.md</a:t>
+              <a:t>LIVE. Ten-minute break before this chapter. Pairs work from exercises/unguided/C2_W01_D04_pushback_STUDENT.md</a:t>
             </a:r>
           </a:p>
           <a:p>
@@ -1372,7 +1372,7 @@
           </a:p>
           <a:p>
             <a:r>
-              <a:t>and the brief is exercises/unguided/C2_W01_D04_escalated_case_STUDENT.md. The support TA answers</a:t>
+              <a:t>and the brief is exercises/unguided/C2_W01_D04_escalated_STUDENT.md. The support TA answers</a:t>
             </a:r>
           </a:p>
           <a:p>

</xml_diff>

<commit_message>
W01 D4: pass 4 fixes: 8 of 44 zero totals, chapter 2's harm stated as scale, chapter 6's chance reference shuffles segment labels (0.82), the hold-back priced and its power deferred, the exposure extract explained, the half-tier test at Rs 5,500; decks rebuilt
Co-Authored-By: Claude Opus 5.5 <noreply@anthropic.com>
Claude-Session: https://claude.ai/code/session_0135Y26sKyTbiUv8BMiqJmgn
</commit_message>
<xml_diff>
--- a/content/W01/D4/slides/C2_W01_D04_half2_STUDENT.pptx
+++ b/content/W01/D4/slides/C2_W01_D04_half2_STUDENT.pptx
@@ -620,12 +620,7 @@
           <a:lstStyle/>
           <a:p>
             <a:r>
-              <a:t>LIVE, 4 minutes. The first line is Retail-Plus, the second Retail-Core, from notebook 6, level 3.</a:t>
-            </a:r>
-          </a:p>
-          <a:p>
-            <a:r>
-              <a:t>Point at May to June: a fall of more than half, no campaign anywhere. A month's revenue on a few</a:t>
+              <a:t>LIVE, 4 minutes. Notebook 6, level 3, draws these two rows as lines. Point at May to June: a fall of more than half, no campaign anywhere. A month's revenue on a few</a:t>
             </a:r>
           </a:p>
           <a:p>
@@ -700,17 +695,17 @@
           <a:lstStyle/>
           <a:p>
             <a:r>
-              <a:t>LIVE, 3 minutes. The chance reference deals each of Retail-Plus's delivered Q2 orders to a month at</a:t>
-            </a:r>
-          </a:p>
-          <a:p>
-            <a:r>
-              <a:t>random, 5,000 times, and asks how often August takes at least 52.5 percent of the quarter. About 6</a:t>
-            </a:r>
-          </a:p>
-          <a:p>
-            <a:r>
-              <a:t>in 100: not rare. What changed: a 170 percent claim shrinks to "cannot tell from months".</a:t>
+              <a:t>LIVE, 3 minutes. The chance reference pools both segments' delivered Q2 orders and deals the segment</a:t>
+            </a:r>
+          </a:p>
+          <a:p>
+            <a:r>
+              <a:t>labels at random, 5,000 times, asking how often the two Augusts differ by four points or more either</a:t>
+            </a:r>
+          </a:p>
+          <a:p>
+            <a:r>
+              <a:t>way. About 8 in 10: no sign. What changed: a 170 percent claim shrinks to "no sign in the months".</a:t>
             </a:r>
           </a:p>
         </p:txBody>
@@ -1400,12 +1395,7 @@
           </a:p>
           <a:p>
             <a:r>
-              <a:t>and Kavya's review (1). Notebook 6 runs beside it. The chapter opener prints 06 because the</a:t>
-            </a:r>
-          </a:p>
-          <a:p>
-            <a:r>
-              <a:t>afternoon deck is renumbered after it is built; see the day sheet.</a:t>
+              <a:t>and Kavya's review (1). Notebook 6 runs beside it.</a:t>
             </a:r>
           </a:p>
         </p:txBody>
@@ -2535,12 +2525,12 @@
           <a:lstStyle/>
           <a:p>
             <a:r>
-              <a:t>LIVE, 9 minutes. Run kahoot/C2_W01_D04_quiz_STUDENT.md. Stop after item 2 and item 5 for thirty</a:t>
-            </a:r>
-          </a:p>
-          <a:p>
-            <a:r>
-              <a:t>seconds each; they are the two traps of the day.</a:t>
+              <a:t>LIVE, 9 minutes. Run kahoot/C2_W01_D04_quiz_STUDENT.md. Stop after item 2 and item 7 for thirty</a:t>
+            </a:r>
+          </a:p>
+          <a:p>
+            <a:r>
+              <a:t>seconds each: the p-value read as the chance of being wrong, and significance read as importance.</a:t>
             </a:r>
           </a:p>
         </p:txBody>
@@ -7119,30 +7109,505 @@
           </a:p>
         </p:txBody>
       </p:sp>
-      <p:pic>
-        <p:nvPicPr>
-          <p:cNvPr id="9" name="mermaid diagram" descr="e854c26afdaa81e5.png"/>
-          <p:cNvPicPr>
-            <a:picLocks noChangeAspect="1"/>
-          </p:cNvPicPr>
-          <p:nvPr/>
-        </p:nvPicPr>
-        <p:blipFill>
-          <a:blip r:embed="rId5"/>
-          <a:stretch>
-            <a:fillRect/>
-          </a:stretch>
-        </p:blipFill>
-        <p:spPr>
-          <a:xfrm>
-            <a:off x="2845155" y="1664208"/>
-            <a:ext cx="6501384" cy="3250692"/>
-          </a:xfrm>
-          <a:prstGeom prst="rect">
-            <a:avLst/>
-          </a:prstGeom>
-        </p:spPr>
-      </p:pic>
+      <p:graphicFrame>
+        <p:nvGraphicFramePr>
+          <p:cNvPr id="9" name="Table 8"/>
+          <p:cNvGraphicFramePr>
+            <a:graphicFrameLocks noGrp="1"/>
+          </p:cNvGraphicFramePr>
+          <p:nvPr/>
+        </p:nvGraphicFramePr>
+        <p:xfrm>
+          <a:off x="530352" y="1956816"/>
+          <a:ext cx="11130991" cy="1005840"/>
+        </p:xfrm>
+        <a:graphic>
+          <a:graphicData uri="http://schemas.openxmlformats.org/drawingml/2006/table">
+            <a:tbl>
+              <a:tblPr firstRow="0" bandRow="0">
+                <a:tableStyleId>{2D5ABB26-0587-4C30-8999-92F81FD0307C}</a:tableStyleId>
+              </a:tblPr>
+              <a:tblGrid>
+                <a:gridCol w="5644591"/>
+                <a:gridCol w="914400"/>
+                <a:gridCol w="914400"/>
+                <a:gridCol w="914400"/>
+                <a:gridCol w="914400"/>
+                <a:gridCol w="914400"/>
+                <a:gridCol w="914400"/>
+              </a:tblGrid>
+              <a:tr h="335280">
+                <a:tc>
+                  <a:txBody>
+                    <a:bodyPr/>
+                    <a:lstStyle/>
+                    <a:p>
+                      <a:r>
+                        <a:rPr sz="1250" b="1" i="0">
+                          <a:solidFill>
+                            <a:srgbClr val="FFFFFF"/>
+                          </a:solidFill>
+                          <a:latin typeface="Calibri"/>
+                        </a:rPr>
+                        <a:t>Delivered, Rs</a:t>
+                      </a:r>
+                    </a:p>
+                  </a:txBody>
+                  <a:tcPr marL="101600" marR="101600" marT="38100" marB="38100" anchor="ctr">
+                    <a:solidFill>
+                      <a:srgbClr val="1A0F5C"/>
+                    </a:solidFill>
+                  </a:tcPr>
+                </a:tc>
+                <a:tc>
+                  <a:txBody>
+                    <a:bodyPr/>
+                    <a:lstStyle/>
+                    <a:p>
+                      <a:r>
+                        <a:rPr sz="1250" b="1" i="0">
+                          <a:solidFill>
+                            <a:srgbClr val="FFFFFF"/>
+                          </a:solidFill>
+                          <a:latin typeface="Calibri"/>
+                        </a:rPr>
+                        <a:t>Apr</a:t>
+                      </a:r>
+                    </a:p>
+                  </a:txBody>
+                  <a:tcPr marL="101600" marR="101600" marT="38100" marB="38100" anchor="ctr">
+                    <a:solidFill>
+                      <a:srgbClr val="1A0F5C"/>
+                    </a:solidFill>
+                  </a:tcPr>
+                </a:tc>
+                <a:tc>
+                  <a:txBody>
+                    <a:bodyPr/>
+                    <a:lstStyle/>
+                    <a:p>
+                      <a:r>
+                        <a:rPr sz="1250" b="1" i="0">
+                          <a:solidFill>
+                            <a:srgbClr val="FFFFFF"/>
+                          </a:solidFill>
+                          <a:latin typeface="Calibri"/>
+                        </a:rPr>
+                        <a:t>May</a:t>
+                      </a:r>
+                    </a:p>
+                  </a:txBody>
+                  <a:tcPr marL="101600" marR="101600" marT="38100" marB="38100" anchor="ctr">
+                    <a:solidFill>
+                      <a:srgbClr val="1A0F5C"/>
+                    </a:solidFill>
+                  </a:tcPr>
+                </a:tc>
+                <a:tc>
+                  <a:txBody>
+                    <a:bodyPr/>
+                    <a:lstStyle/>
+                    <a:p>
+                      <a:r>
+                        <a:rPr sz="1250" b="1" i="0">
+                          <a:solidFill>
+                            <a:srgbClr val="FFFFFF"/>
+                          </a:solidFill>
+                          <a:latin typeface="Calibri"/>
+                        </a:rPr>
+                        <a:t>Jun</a:t>
+                      </a:r>
+                    </a:p>
+                  </a:txBody>
+                  <a:tcPr marL="101600" marR="101600" marT="38100" marB="38100" anchor="ctr">
+                    <a:solidFill>
+                      <a:srgbClr val="1A0F5C"/>
+                    </a:solidFill>
+                  </a:tcPr>
+                </a:tc>
+                <a:tc>
+                  <a:txBody>
+                    <a:bodyPr/>
+                    <a:lstStyle/>
+                    <a:p>
+                      <a:r>
+                        <a:rPr sz="1250" b="1" i="0">
+                          <a:solidFill>
+                            <a:srgbClr val="FFFFFF"/>
+                          </a:solidFill>
+                          <a:latin typeface="Calibri"/>
+                        </a:rPr>
+                        <a:t>Jul</a:t>
+                      </a:r>
+                    </a:p>
+                  </a:txBody>
+                  <a:tcPr marL="101600" marR="101600" marT="38100" marB="38100" anchor="ctr">
+                    <a:solidFill>
+                      <a:srgbClr val="1A0F5C"/>
+                    </a:solidFill>
+                  </a:tcPr>
+                </a:tc>
+                <a:tc>
+                  <a:txBody>
+                    <a:bodyPr/>
+                    <a:lstStyle/>
+                    <a:p>
+                      <a:r>
+                        <a:rPr sz="1250" b="1" i="0">
+                          <a:solidFill>
+                            <a:srgbClr val="FFFFFF"/>
+                          </a:solidFill>
+                          <a:latin typeface="Calibri"/>
+                        </a:rPr>
+                        <a:t>Aug</a:t>
+                      </a:r>
+                    </a:p>
+                  </a:txBody>
+                  <a:tcPr marL="101600" marR="101600" marT="38100" marB="38100" anchor="ctr">
+                    <a:solidFill>
+                      <a:srgbClr val="1A0F5C"/>
+                    </a:solidFill>
+                  </a:tcPr>
+                </a:tc>
+                <a:tc>
+                  <a:txBody>
+                    <a:bodyPr/>
+                    <a:lstStyle/>
+                    <a:p>
+                      <a:r>
+                        <a:rPr sz="1250" b="1" i="0">
+                          <a:solidFill>
+                            <a:srgbClr val="FFFFFF"/>
+                          </a:solidFill>
+                          <a:latin typeface="Calibri"/>
+                        </a:rPr>
+                        <a:t>Sep</a:t>
+                      </a:r>
+                    </a:p>
+                  </a:txBody>
+                  <a:tcPr marL="101600" marR="101600" marT="38100" marB="38100" anchor="ctr">
+                    <a:solidFill>
+                      <a:srgbClr val="1A0F5C"/>
+                    </a:solidFill>
+                  </a:tcPr>
+                </a:tc>
+              </a:tr>
+              <a:tr h="335280">
+                <a:tc>
+                  <a:txBody>
+                    <a:bodyPr/>
+                    <a:lstStyle/>
+                    <a:p>
+                      <a:r>
+                        <a:rPr sz="1200" b="0" i="0">
+                          <a:solidFill>
+                            <a:srgbClr val="1A1440"/>
+                          </a:solidFill>
+                          <a:latin typeface="Calibri"/>
+                        </a:rPr>
+                        <a:t>Retail-Plus, targeted</a:t>
+                      </a:r>
+                    </a:p>
+                  </a:txBody>
+                  <a:tcPr marL="101600" marR="101600" marT="38100" marB="38100" anchor="ctr">
+                    <a:solidFill>
+                      <a:srgbClr val="FFFFFF"/>
+                    </a:solidFill>
+                  </a:tcPr>
+                </a:tc>
+                <a:tc>
+                  <a:txBody>
+                    <a:bodyPr/>
+                    <a:lstStyle/>
+                    <a:p>
+                      <a:r>
+                        <a:rPr sz="1200" b="0" i="0">
+                          <a:solidFill>
+                            <a:srgbClr val="1A1440"/>
+                          </a:solidFill>
+                          <a:latin typeface="Calibri"/>
+                        </a:rPr>
+                        <a:t>19,650</a:t>
+                      </a:r>
+                    </a:p>
+                  </a:txBody>
+                  <a:tcPr marL="101600" marR="101600" marT="38100" marB="38100" anchor="ctr">
+                    <a:solidFill>
+                      <a:srgbClr val="FFFFFF"/>
+                    </a:solidFill>
+                  </a:tcPr>
+                </a:tc>
+                <a:tc>
+                  <a:txBody>
+                    <a:bodyPr/>
+                    <a:lstStyle/>
+                    <a:p>
+                      <a:r>
+                        <a:rPr sz="1200" b="0" i="0">
+                          <a:solidFill>
+                            <a:srgbClr val="1A1440"/>
+                          </a:solidFill>
+                          <a:latin typeface="Calibri"/>
+                        </a:rPr>
+                        <a:t>36,840</a:t>
+                      </a:r>
+                    </a:p>
+                  </a:txBody>
+                  <a:tcPr marL="101600" marR="101600" marT="38100" marB="38100" anchor="ctr">
+                    <a:solidFill>
+                      <a:srgbClr val="FFFFFF"/>
+                    </a:solidFill>
+                  </a:tcPr>
+                </a:tc>
+                <a:tc>
+                  <a:txBody>
+                    <a:bodyPr/>
+                    <a:lstStyle/>
+                    <a:p>
+                      <a:r>
+                        <a:rPr sz="1200" b="0" i="0">
+                          <a:solidFill>
+                            <a:srgbClr val="1A1440"/>
+                          </a:solidFill>
+                          <a:latin typeface="Calibri"/>
+                        </a:rPr>
+                        <a:t>15,640</a:t>
+                      </a:r>
+                    </a:p>
+                  </a:txBody>
+                  <a:tcPr marL="101600" marR="101600" marT="38100" marB="38100" anchor="ctr">
+                    <a:solidFill>
+                      <a:srgbClr val="FFFFFF"/>
+                    </a:solidFill>
+                  </a:tcPr>
+                </a:tc>
+                <a:tc>
+                  <a:txBody>
+                    <a:bodyPr/>
+                    <a:lstStyle/>
+                    <a:p>
+                      <a:r>
+                        <a:rPr sz="1200" b="0" i="0">
+                          <a:solidFill>
+                            <a:srgbClr val="1A1440"/>
+                          </a:solidFill>
+                          <a:latin typeface="Calibri"/>
+                        </a:rPr>
+                        <a:t>9,280</a:t>
+                      </a:r>
+                    </a:p>
+                  </a:txBody>
+                  <a:tcPr marL="101600" marR="101600" marT="38100" marB="38100" anchor="ctr">
+                    <a:solidFill>
+                      <a:srgbClr val="FFFFFF"/>
+                    </a:solidFill>
+                  </a:tcPr>
+                </a:tc>
+                <a:tc>
+                  <a:txBody>
+                    <a:bodyPr/>
+                    <a:lstStyle/>
+                    <a:p>
+                      <a:r>
+                        <a:rPr sz="1200" b="0" i="0">
+                          <a:solidFill>
+                            <a:srgbClr val="1A1440"/>
+                          </a:solidFill>
+                          <a:latin typeface="Calibri"/>
+                        </a:rPr>
+                        <a:t>25,060</a:t>
+                      </a:r>
+                    </a:p>
+                  </a:txBody>
+                  <a:tcPr marL="101600" marR="101600" marT="38100" marB="38100" anchor="ctr">
+                    <a:solidFill>
+                      <a:srgbClr val="FFFFFF"/>
+                    </a:solidFill>
+                  </a:tcPr>
+                </a:tc>
+                <a:tc>
+                  <a:txBody>
+                    <a:bodyPr/>
+                    <a:lstStyle/>
+                    <a:p>
+                      <a:r>
+                        <a:rPr sz="1200" b="0" i="0">
+                          <a:solidFill>
+                            <a:srgbClr val="1A1440"/>
+                          </a:solidFill>
+                          <a:latin typeface="Calibri"/>
+                        </a:rPr>
+                        <a:t>13,370</a:t>
+                      </a:r>
+                    </a:p>
+                  </a:txBody>
+                  <a:tcPr marL="101600" marR="101600" marT="38100" marB="38100" anchor="ctr">
+                    <a:solidFill>
+                      <a:srgbClr val="FFFFFF"/>
+                    </a:solidFill>
+                  </a:tcPr>
+                </a:tc>
+              </a:tr>
+              <a:tr h="335280">
+                <a:tc>
+                  <a:txBody>
+                    <a:bodyPr/>
+                    <a:lstStyle/>
+                    <a:p>
+                      <a:r>
+                        <a:rPr sz="1200" b="0" i="0">
+                          <a:solidFill>
+                            <a:srgbClr val="1A1440"/>
+                          </a:solidFill>
+                          <a:latin typeface="Calibri"/>
+                        </a:rPr>
+                        <a:t>Retail-Core, not targeted</a:t>
+                      </a:r>
+                    </a:p>
+                  </a:txBody>
+                  <a:tcPr marL="101600" marR="101600" marT="38100" marB="38100" anchor="ctr">
+                    <a:solidFill>
+                      <a:srgbClr val="F4F2FA"/>
+                    </a:solidFill>
+                  </a:tcPr>
+                </a:tc>
+                <a:tc>
+                  <a:txBody>
+                    <a:bodyPr/>
+                    <a:lstStyle/>
+                    <a:p>
+                      <a:r>
+                        <a:rPr sz="1200" b="0" i="0">
+                          <a:solidFill>
+                            <a:srgbClr val="1A1440"/>
+                          </a:solidFill>
+                          <a:latin typeface="Calibri"/>
+                        </a:rPr>
+                        <a:t>11,920</a:t>
+                      </a:r>
+                    </a:p>
+                  </a:txBody>
+                  <a:tcPr marL="101600" marR="101600" marT="38100" marB="38100" anchor="ctr">
+                    <a:solidFill>
+                      <a:srgbClr val="F4F2FA"/>
+                    </a:solidFill>
+                  </a:tcPr>
+                </a:tc>
+                <a:tc>
+                  <a:txBody>
+                    <a:bodyPr/>
+                    <a:lstStyle/>
+                    <a:p>
+                      <a:r>
+                        <a:rPr sz="1200" b="0" i="0">
+                          <a:solidFill>
+                            <a:srgbClr val="1A1440"/>
+                          </a:solidFill>
+                          <a:latin typeface="Calibri"/>
+                        </a:rPr>
+                        <a:t>15,000</a:t>
+                      </a:r>
+                    </a:p>
+                  </a:txBody>
+                  <a:tcPr marL="101600" marR="101600" marT="38100" marB="38100" anchor="ctr">
+                    <a:solidFill>
+                      <a:srgbClr val="F4F2FA"/>
+                    </a:solidFill>
+                  </a:tcPr>
+                </a:tc>
+                <a:tc>
+                  <a:txBody>
+                    <a:bodyPr/>
+                    <a:lstStyle/>
+                    <a:p>
+                      <a:r>
+                        <a:rPr sz="1200" b="0" i="0">
+                          <a:solidFill>
+                            <a:srgbClr val="1A1440"/>
+                          </a:solidFill>
+                          <a:latin typeface="Calibri"/>
+                        </a:rPr>
+                        <a:t>24,380</a:t>
+                      </a:r>
+                    </a:p>
+                  </a:txBody>
+                  <a:tcPr marL="101600" marR="101600" marT="38100" marB="38100" anchor="ctr">
+                    <a:solidFill>
+                      <a:srgbClr val="F4F2FA"/>
+                    </a:solidFill>
+                  </a:tcPr>
+                </a:tc>
+                <a:tc>
+                  <a:txBody>
+                    <a:bodyPr/>
+                    <a:lstStyle/>
+                    <a:p>
+                      <a:r>
+                        <a:rPr sz="1200" b="0" i="0">
+                          <a:solidFill>
+                            <a:srgbClr val="1A1440"/>
+                          </a:solidFill>
+                          <a:latin typeface="Calibri"/>
+                        </a:rPr>
+                        <a:t>13,320</a:t>
+                      </a:r>
+                    </a:p>
+                  </a:txBody>
+                  <a:tcPr marL="101600" marR="101600" marT="38100" marB="38100" anchor="ctr">
+                    <a:solidFill>
+                      <a:srgbClr val="F4F2FA"/>
+                    </a:solidFill>
+                  </a:tcPr>
+                </a:tc>
+                <a:tc>
+                  <a:txBody>
+                    <a:bodyPr/>
+                    <a:lstStyle/>
+                    <a:p>
+                      <a:r>
+                        <a:rPr sz="1200" b="0" i="0">
+                          <a:solidFill>
+                            <a:srgbClr val="1A1440"/>
+                          </a:solidFill>
+                          <a:latin typeface="Calibri"/>
+                        </a:rPr>
+                        <a:t>23,090</a:t>
+                      </a:r>
+                    </a:p>
+                  </a:txBody>
+                  <a:tcPr marL="101600" marR="101600" marT="38100" marB="38100" anchor="ctr">
+                    <a:solidFill>
+                      <a:srgbClr val="F4F2FA"/>
+                    </a:solidFill>
+                  </a:tcPr>
+                </a:tc>
+                <a:tc>
+                  <a:txBody>
+                    <a:bodyPr/>
+                    <a:lstStyle/>
+                    <a:p>
+                      <a:r>
+                        <a:rPr sz="1200" b="0" i="0">
+                          <a:solidFill>
+                            <a:srgbClr val="1A1440"/>
+                          </a:solidFill>
+                          <a:latin typeface="Calibri"/>
+                        </a:rPr>
+                        <a:t>11,140</a:t>
+                      </a:r>
+                    </a:p>
+                  </a:txBody>
+                  <a:tcPr marL="101600" marR="101600" marT="38100" marB="38100" anchor="ctr">
+                    <a:solidFill>
+                      <a:srgbClr val="F4F2FA"/>
+                    </a:solidFill>
+                  </a:tcPr>
+                </a:tc>
+              </a:tr>
+            </a:tbl>
+          </a:graphicData>
+        </a:graphic>
+      </p:graphicFrame>
       <p:sp>
         <p:nvSpPr>
           <p:cNvPr id="10" name="Rounded Rectangle 9"/>
@@ -7151,7 +7616,7 @@
         </p:nvSpPr>
         <p:spPr>
           <a:xfrm>
-            <a:off x="530352" y="4960620"/>
+            <a:off x="530352" y="3218688"/>
             <a:ext cx="11130991" cy="1074420"/>
           </a:xfrm>
           <a:prstGeom prst="roundRect">
@@ -7199,7 +7664,7 @@
         </p:nvSpPr>
         <p:spPr>
           <a:xfrm>
-            <a:off x="676656" y="5088636"/>
+            <a:off x="676656" y="3346704"/>
             <a:ext cx="45720" cy="818388"/>
           </a:xfrm>
           <a:prstGeom prst="roundRect">
@@ -7245,7 +7710,7 @@
         </p:nvSpPr>
         <p:spPr>
           <a:xfrm>
-            <a:off x="877824" y="5079492"/>
+            <a:off x="877824" y="3337560"/>
             <a:ext cx="10564063" cy="891540"/>
           </a:xfrm>
           <a:prstGeom prst="rect">
@@ -8358,7 +8823,7 @@
                 </a:solidFill>
                 <a:latin typeface="Georgia"/>
               </a:rPr>
-              <a:t>6 in 100</a:t>
+              <a:t>8 in 10</a:t>
             </a:r>
           </a:p>
         </p:txBody>
@@ -8428,7 +8893,7 @@
                 </a:solidFill>
                 <a:latin typeface="Calibri"/>
               </a:rPr>
-              <a:t>deals that give Retail-Plus's August that share</a:t>
+              <a:t>label shuffles that make a 4-point gap either way</a:t>
             </a:r>
           </a:p>
         </p:txBody>
@@ -8511,7 +8976,7 @@
                 </a:solidFill>
                 <a:latin typeface="Calibri"/>
               </a:rPr>
-              <a:t>The 170 percent becomes an August four points busier than the untargeted segment's, a gap chance alone reaches often enough. The month file cannot separate the sale from a busy August.</a:t>
+              <a:t>The 170 percent becomes an August four points busier than the untargeted segment's, a gap chance makes most of the time. The months show no sign of the sale beyond a busy August for everyone.</a:t>
             </a:r>
           </a:p>
         </p:txBody>
@@ -9268,7 +9733,7 @@
       </p:sp>
       <p:pic>
         <p:nvPicPr>
-          <p:cNvPr id="9" name="mermaid diagram" descr="2b7ad7b778984687.png"/>
+          <p:cNvPr id="9" name="mermaid diagram" descr="6f8f5956c994e8e8.png"/>
           <p:cNvPicPr>
             <a:picLocks noChangeAspect="1"/>
           </p:cNvPicPr>
@@ -9282,8 +9747,8 @@
         </p:blipFill>
         <p:spPr>
           <a:xfrm>
-            <a:off x="1674537" y="1682496"/>
-            <a:ext cx="2497955" cy="4517136"/>
+            <a:off x="530352" y="1956816"/>
+            <a:ext cx="11130991" cy="2092677"/>
           </a:xfrm>
           <a:prstGeom prst="rect">
             <a:avLst/>
@@ -9298,8 +9763,8 @@
         </p:nvSpPr>
         <p:spPr>
           <a:xfrm>
-            <a:off x="5761917" y="1956816"/>
-            <a:ext cx="5899425" cy="1074420"/>
+            <a:off x="530352" y="4195797"/>
+            <a:ext cx="11130991" cy="1074420"/>
           </a:xfrm>
           <a:prstGeom prst="roundRect">
             <a:avLst>
@@ -9346,7 +9811,7 @@
         </p:nvSpPr>
         <p:spPr>
           <a:xfrm>
-            <a:off x="5908221" y="2084832"/>
+            <a:off x="676656" y="4323813"/>
             <a:ext cx="45720" cy="818388"/>
           </a:xfrm>
           <a:prstGeom prst="roundRect">
@@ -9392,8 +9857,8 @@
         </p:nvSpPr>
         <p:spPr>
           <a:xfrm>
-            <a:off x="6109389" y="2075688"/>
-            <a:ext cx="5332497" cy="891540"/>
+            <a:off x="877824" y="4314669"/>
+            <a:ext cx="10564063" cy="891540"/>
           </a:xfrm>
           <a:prstGeom prst="rect">
             <a:avLst/>
@@ -9413,7 +9878,7 @@
                 </a:solidFill>
                 <a:latin typeface="Calibri"/>
               </a:rPr>
-              <a:t>The price of knowing. </a:t>
+              <a:t>The cost of the hold-back. </a:t>
             </a:r>
             <a:r>
               <a:rPr sz="1500" b="0" i="0">
@@ -9422,7 +9887,7 @@
                 </a:solidFill>
                 <a:latin typeface="Calibri"/>
               </a:rPr>
-              <a:t>Holding back 14 of 70 Retail-Plus customers at Marketing's own 6 percent lift forgoes about Rs 4,200, and nothing if the lift is not real.</a:t>
+              <a:t>Holding back 14 of 70 Retail-Plus customers at Marketing's own 6 percent lift forgoes about Rs 4,200, and nothing if the lift is not real. Fourteen are too few to see a 6 percent lift; sizing the hold-back is a question of power, which comes later.</a:t>
             </a:r>
           </a:p>
         </p:txBody>
@@ -10303,7 +10768,7 @@
                           </a:solidFill>
                           <a:latin typeface="Calibri"/>
                         </a:rPr>
-                        <a:t>August's share 4 points higher, chance makes that about 6 in 100</a:t>
+                        <a:t>August's share 4 points higher, which the label shuffle makes about 8 times in 10</a:t>
                       </a:r>
                     </a:p>
                   </a:txBody>
@@ -10325,7 +10790,7 @@
                           </a:solidFill>
                           <a:latin typeface="Calibri"/>
                         </a:rPr>
-                        <a:t>Cannot tell</a:t>
+                        <a:t>No sign of the sale</a:t>
                       </a:r>
                     </a:p>
                   </a:txBody>
@@ -11297,7 +11762,7 @@
       </p:sp>
       <p:pic>
         <p:nvPicPr>
-          <p:cNvPr id="9" name="mermaid diagram" descr="75548508a7901396.png"/>
+          <p:cNvPr id="9" name="mermaid diagram" descr="111d5a52647ef440.png"/>
           <p:cNvPicPr>
             <a:picLocks noChangeAspect="1"/>
           </p:cNvPicPr>
@@ -11505,7 +11970,7 @@
                 </a:solidFill>
                 <a:latin typeface="Calibri"/>
               </a:rPr>
-              <a:t>Two routes find no lift, and you priced the test that would settle it. Take that to Marketing as an offer, never as a verdict on their work.</a:t>
+              <a:t>Two routes find no lift, and you priced the hold-back and said what it cannot yet size. Take that to Marketing as an offer, never as a verdict on their work.</a:t>
             </a:r>
           </a:p>
         </p:txBody>

</xml_diff>

<commit_message>
W01 D4: second-round review fixes: every Business comparison out of the fall's sizing, Retail-Core named an imperfect comparison in chapter 6, eight zeros in the chapter 1 set, Kahoot Q8 plant-free; decks and notebooks rebuilt; depth loop logged
Co-Authored-By: Claude Opus 5.5 <noreply@anthropic.com>
Claude-Session: https://claude.ai/code/session_0135Y26sKyTbiUv8BMiqJmgn
</commit_message>
<xml_diff>
--- a/content/W01/D4/slides/C2_W01_D04_half2_STUDENT.pptx
+++ b/content/W01/D4/slides/C2_W01_D04_half2_STUDENT.pptx
@@ -7461,7 +7461,7 @@
                           </a:solidFill>
                           <a:latin typeface="Calibri"/>
                         </a:rPr>
-                        <a:t>Retail-Core, not targeted</a:t>
+                        <a:t>Retail-Core, not aimed at</a:t>
                       </a:r>
                     </a:p>
                   </a:txBody>
@@ -7740,7 +7740,7 @@
                 </a:solidFill>
                 <a:latin typeface="Calibri"/>
               </a:rPr>
-              <a:t>Retail-Core, the segment the sale was not aimed at, rose 73 percent from July to August. Retail-Plus fell 58 percent from May to June with no sale running. July's Retail-Plus figure stands on 4 delivered orders.</a:t>
+              <a:t>Retail-Core, the segment the sale was not aimed at (though the extract shows it reached some Retail-Core customers), rose 73 percent from July to August. Retail-Plus fell 58 percent from May to June with no sale running. July's Retail-Plus figure stands on 4 delivered orders.</a:t>
             </a:r>
           </a:p>
         </p:txBody>
@@ -8744,7 +8744,7 @@
                 </a:solidFill>
                 <a:latin typeface="Calibri"/>
               </a:rPr>
-              <a:t>August's share of its Q2, not targeted</a:t>
+              <a:t>August's share of its Q2, not aimed at</a:t>
             </a:r>
           </a:p>
         </p:txBody>
@@ -10652,7 +10652,7 @@
         </p:nvGraphicFramePr>
         <p:xfrm>
           <a:off x="530352" y="1956816"/>
-          <a:ext cx="11130989" cy="1593088"/>
+          <a:ext cx="11130991" cy="1593088"/>
         </p:xfrm>
         <a:graphic>
           <a:graphicData uri="http://schemas.openxmlformats.org/drawingml/2006/table">
@@ -10661,9 +10661,9 @@
                 <a:tableStyleId>{2D5ABB26-0587-4C30-8999-92F81FD0307C}</a:tableStyleId>
               </a:tblPr>
               <a:tblGrid>
-                <a:gridCol w="2924602"/>
-                <a:gridCol w="5462399"/>
-                <a:gridCol w="2743988"/>
+                <a:gridCol w="2350551"/>
+                <a:gridCol w="4390220"/>
+                <a:gridCol w="4390220"/>
               </a:tblGrid>
               <a:tr h="369824">
                 <a:tc>
@@ -10790,7 +10790,7 @@
                           </a:solidFill>
                           <a:latin typeface="Calibri"/>
                         </a:rPr>
-                        <a:t>No sign of the sale</a:t>
+                        <a:t>No sign; Retail-Core was partly reached, so it is an imperfect comparison</a:t>
                       </a:r>
                     </a:p>
                   </a:txBody>

</xml_diff>

<commit_message>
W01 D4: afternoon deck rebuilt from its markdown after the S10 and S20 speaker notes changed
Co-Authored-By: Claude Opus 5.5 <noreply@anthropic.com>
Claude-Session: https://claude.ai/code/session_01P7zaoR4dQ5pzBFnsX549JQ
</commit_message>
<xml_diff>
--- a/content/W01/D4/slides/C2_W01_D04_half2_STUDENT.pptx
+++ b/content/W01/D4/slides/C2_W01_D04_half2_STUDENT.pptx
@@ -785,42 +785,42 @@
           <a:lstStyle/>
           <a:p>
             <a:r>
-              <a:t>LIVE, 4 minutes. Meet the two lists head-on. The morning offered the retention test to "the whole</a:t>
-            </a:r>
-          </a:p>
-          <a:p>
-            <a:r>
-              <a:t>tier" of 22, and this hold-back takes 14 of 70. Both are right: the 22 are Finance's order file, where</a:t>
-            </a:r>
-          </a:p>
-          <a:p>
-            <a:r>
-              <a:t>Retail-Plus members delivered about Rs 1,139 each in August; the 70 are the platform's list, where</a:t>
-            </a:r>
-          </a:p>
-          <a:p>
-            <a:r>
-              <a:t>Retail-Plus customers who did not get the sale averaged Rs 5,000. Different ids and different</a:t>
-            </a:r>
-          </a:p>
-          <a:p>
-            <a:r>
-              <a:t>measures, delivered revenue per member against the platform's average spend, so neither checks the</a:t>
-            </a:r>
-          </a:p>
-          <a:p>
-            <a:r>
-              <a:t>other. Fourteen are too few to see a 6 percent lift; sizing a hold-back is power, which comes later.</a:t>
-            </a:r>
-          </a:p>
-          <a:p>
-            <a:r>
-              <a:t>Chance decides who gets the sale, so the groups are alike in everything else on average, including</a:t>
-            </a:r>
-          </a:p>
-          <a:p>
-            <a:r>
-              <a:t>who was going to buy anyway.</a:t>
+              <a:t>LIVE, 4 minutes. Meet the two lists head-on. The morning priced the retention offer on "the whole</a:t>
+            </a:r>
+          </a:p>
+          <a:p>
+            <a:r>
+              <a:t>tier" of 22 and tests it on half of them, and this hold-back takes 14 of 70. Both are right: the 22</a:t>
+            </a:r>
+          </a:p>
+          <a:p>
+            <a:r>
+              <a:t>are Finance's order file, where Retail-Plus members delivered about Rs 1,139 each in August; the 70</a:t>
+            </a:r>
+          </a:p>
+          <a:p>
+            <a:r>
+              <a:t>are the platform's list, where Retail-Plus customers who did not get the sale averaged Rs 5,000.</a:t>
+            </a:r>
+          </a:p>
+          <a:p>
+            <a:r>
+              <a:t>Different ids and different measures, delivered revenue per member against the platform's average</a:t>
+            </a:r>
+          </a:p>
+          <a:p>
+            <a:r>
+              <a:t>spend, so neither checks the other. Fourteen are too few to see a 6 percent lift; sizing a hold-back</a:t>
+            </a:r>
+          </a:p>
+          <a:p>
+            <a:r>
+              <a:t>is power, which comes later. Chance decides who gets the sale, so the groups are alike in everything</a:t>
+            </a:r>
+          </a:p>
+          <a:p>
+            <a:r>
+              <a:t>else on average, including who was going to buy anyway.</a:t>
             </a:r>
           </a:p>
         </p:txBody>
@@ -1820,7 +1820,7 @@
           <a:lstStyle/>
           <a:p>
             <a:r>
-              <a:t>LIVE, 2 minutes. Move 4 is spoken, never written first. The partner playing Marketing is allowed to</a:t>
+              <a:t>LIVE, 2 minutes. Move 4 is spoken before anything is written. The partner playing Marketing is allowed to</a:t>
             </a:r>
           </a:p>
           <a:p>

</xml_diff>

<commit_message>
W01 D4: both decks rebuilt from their current markdown
Co-Authored-By: Claude Opus 5.5 <noreply@anthropic.com>
Claude-Session: https://claude.ai/code/session_01FuBiPzJ5MbkU3CtQUt4t8P
</commit_message>
<xml_diff>
--- a/content/W01/D4/slides/C2_W01_D04_half2_STUDENT.pptx
+++ b/content/W01/D4/slides/C2_W01_D04_half2_STUDENT.pptx
@@ -2008,7 +2008,7 @@
           <a:lstStyle/>
           <a:p>
             <a:r>
-              <a:t>LIVE, 3 minutes. Move 4 is spoken before anything is written. The partner playing Marketing is</a:t>
+              <a:t>LIVE, 3 minutes. Part 4 is spoken before anything is written. The partner playing Marketing is</a:t>
             </a:r>
           </a:p>
           <a:p>
@@ -2183,7 +2183,7 @@
           </a:p>
           <a:p>
             <a:r>
-              <a:t>Notebook ex2, move 4, computes the 9.8 percent. Then the interview drill.</a:t>
+              <a:t>Notebook ex2, part 4, computes the 9.8 percent. Then the interview drill.</a:t>
             </a:r>
           </a:p>
         </p:txBody>
@@ -17087,7 +17087,7 @@
         <p:spPr>
           <a:xfrm>
             <a:off x="694944" y="2990088"/>
-            <a:ext cx="1750710" cy="251205"/>
+            <a:ext cx="1750710" cy="465836"/>
           </a:xfrm>
           <a:prstGeom prst="rect">
             <a:avLst/>
@@ -17108,7 +17108,7 @@
                 </a:solidFill>
                 <a:latin typeface="Calibri"/>
               </a:rPr>
-              <a:t>Is it real?</a:t>
+              <a:t>More than the wobble?</a:t>
             </a:r>
           </a:p>
         </p:txBody>
@@ -17121,8 +17121,8 @@
         </p:nvSpPr>
         <p:spPr>
           <a:xfrm>
-            <a:off x="694944" y="3277870"/>
-            <a:ext cx="1750710" cy="531876"/>
+            <a:off x="694944" y="3492500"/>
+            <a:ext cx="1750710" cy="366776"/>
           </a:xfrm>
           <a:prstGeom prst="rect">
             <a:avLst/>
@@ -17143,7 +17143,7 @@
                 </a:solidFill>
                 <a:latin typeface="Calibri"/>
               </a:rPr>
-              <a:t>Retail-Plus, 5,000 flips, seed 2026, counted both ways.</a:t>
+              <a:t>The Retail-Plus fall, counted in both directions.</a:t>
             </a:r>
           </a:p>
         </p:txBody>
@@ -17290,7 +17290,7 @@
         <p:spPr>
           <a:xfrm>
             <a:off x="2957718" y="2990088"/>
-            <a:ext cx="1750710" cy="251205"/>
+            <a:ext cx="1750710" cy="465836"/>
           </a:xfrm>
           <a:prstGeom prst="rect">
             <a:avLst/>
@@ -17311,7 +17311,7 @@
                 </a:solidFill>
                 <a:latin typeface="Calibri"/>
               </a:rPr>
-              <a:t>Is it worth it?</a:t>
+              <a:t>How big, and who is tested?</a:t>
             </a:r>
           </a:p>
         </p:txBody>
@@ -17324,7 +17324,7 @@
         </p:nvSpPr>
         <p:spPr>
           <a:xfrm>
-            <a:off x="2957718" y="3277870"/>
+            <a:off x="2957718" y="3492500"/>
             <a:ext cx="1750710" cy="531876"/>
           </a:xfrm>
           <a:prstGeom prst="rect">
@@ -17346,7 +17346,7 @@
                 </a:solidFill>
                 <a:latin typeface="Calibri"/>
               </a:rPr>
-              <a:t>The fall against the company's quarter, and a coin-chosen half-tier test.</a:t>
+              <a:t>The fall against the company's quarter, and the offer's first test.</a:t>
             </a:r>
           </a:p>
         </p:txBody>
@@ -17514,7 +17514,7 @@
                 </a:solidFill>
                 <a:latin typeface="Calibri"/>
               </a:rPr>
-              <a:t>Can Student carry budget?</a:t>
+              <a:t>What stands behind 40%?</a:t>
             </a:r>
           </a:p>
         </p:txBody>
@@ -17528,7 +17528,7 @@
         <p:spPr>
           <a:xfrm>
             <a:off x="5220492" y="3492500"/>
-            <a:ext cx="1750710" cy="366776"/>
+            <a:ext cx="1750710" cy="531876"/>
           </a:xfrm>
           <a:prstGeom prst="rect">
             <a:avLst/>
@@ -17549,7 +17549,7 @@
                 </a:solidFill>
                 <a:latin typeface="Calibri"/>
               </a:rPr>
-              <a:t>The rate with its count and its chance reference.</a:t>
+              <a:t>Student's orders, and how often chance makes the rise.</a:t>
             </a:r>
           </a:p>
         </p:txBody>
@@ -17717,7 +17717,7 @@
                 </a:solidFill>
                 <a:latin typeface="Calibri"/>
               </a:rPr>
-              <a:t>Did the discount work?</a:t>
+              <a:t>Did the sale lift spend?</a:t>
             </a:r>
           </a:p>
         </p:txBody>
@@ -17752,7 +17752,7 @@
                 </a:solidFill>
                 <a:latin typeface="Calibri"/>
               </a:rPr>
-              <a:t>Did the monsoon sale lift spend, and for whom?</a:t>
+              <a:t>The monsoon sale, and for whom.</a:t>
             </a:r>
           </a:p>
         </p:txBody>
@@ -17926,7 +17926,7 @@
                 </a:solidFill>
                 <a:latin typeface="Calibri"/>
               </a:rPr>
-              <a:t>What does Meera read?</a:t>
+              <a:t>What does the note say?</a:t>
             </a:r>
           </a:p>
         </p:txBody>
@@ -17961,7 +17961,7 @@
                 </a:solidFill>
                 <a:latin typeface="Calibri"/>
               </a:rPr>
-              <a:t>The hold-back sized on the platform's list, then the note under 200 words.</a:t>
+              <a:t>The Diwali hold-back sized, then the note under 200 words.</a:t>
             </a:r>
           </a:p>
         </p:txBody>
@@ -25920,7 +25920,7 @@
                 </a:solidFill>
                 <a:latin typeface="Georgia"/>
               </a:rPr>
-              <a:t>Answered in four moves, before Meera decides</a:t>
+              <a:t>Answered in four parts, before Meera decides</a:t>
             </a:r>
           </a:p>
         </p:txBody>
@@ -25955,7 +25955,7 @@
                 </a:solidFill>
                 <a:latin typeface="Calibri"/>
               </a:rPr>
-              <a:t>Who needs this answer, and which moves lead to it?</a:t>
+              <a:t>Who needs this answer, and which parts lead to it?</a:t>
             </a:r>
           </a:p>
         </p:txBody>
@@ -26249,7 +26249,7 @@
                 </a:solidFill>
                 <a:latin typeface="Calibri"/>
               </a:rPr>
-              <a:t>MOVE 1</a:t>
+              <a:t>PART 1</a:t>
             </a:r>
           </a:p>
         </p:txBody>
@@ -26319,7 +26319,7 @@
                 </a:solidFill>
                 <a:latin typeface="Calibri"/>
               </a:rPr>
-              <a:t>Compute Rs 4,850 and Rs 3,200 from the platform's list.</a:t>
+              <a:t>Make Rs 4,850 and Rs 3,200 appear from the platform's list.</a:t>
             </a:r>
           </a:p>
         </p:txBody>
@@ -26476,7 +26476,7 @@
                 </a:solidFill>
                 <a:latin typeface="Calibri"/>
               </a:rPr>
-              <a:t>MOVE 2</a:t>
+              <a:t>PART 2</a:t>
             </a:r>
           </a:p>
         </p:txBody>
@@ -26525,7 +26525,7 @@
         <p:spPr>
           <a:xfrm>
             <a:off x="3559987" y="4542536"/>
-            <a:ext cx="2243251" cy="399796"/>
+            <a:ext cx="2243251" cy="581406"/>
           </a:xfrm>
           <a:prstGeom prst="rect">
             <a:avLst/>
@@ -26546,7 +26546,7 @@
                 </a:solidFill>
                 <a:latin typeface="Calibri"/>
               </a:rPr>
-              <a:t>Say which customers sit in each group, and what else differs.</a:t>
+              <a:t>Who sits in each of Marketing's two groups, and what else differs.</a:t>
             </a:r>
           </a:p>
         </p:txBody>
@@ -26703,7 +26703,7 @@
                 </a:solidFill>
                 <a:latin typeface="Calibri"/>
               </a:rPr>
-              <a:t>MOVE 3</a:t>
+              <a:t>PART 3</a:t>
             </a:r>
           </a:p>
         </p:txBody>
@@ -26752,7 +26752,7 @@
         <p:spPr>
           <a:xfrm>
             <a:off x="6388455" y="4542536"/>
-            <a:ext cx="2243251" cy="581406"/>
+            <a:ext cx="2243251" cy="399796"/>
           </a:xfrm>
           <a:prstGeom prst="rect">
             <a:avLst/>
@@ -26773,7 +26773,7 @@
                 </a:solidFill>
                 <a:latin typeface="Calibri"/>
               </a:rPr>
-              <a:t>Like for like, inside Retail-Plus, with the counts beside each average.</a:t>
+              <a:t>Like for like, with the customers behind each average.</a:t>
             </a:r>
           </a:p>
         </p:txBody>
@@ -26936,7 +26936,7 @@
                 </a:solidFill>
                 <a:latin typeface="Calibri"/>
               </a:rPr>
-              <a:t>MOVE 4</a:t>
+              <a:t>PART 4</a:t>
             </a:r>
           </a:p>
         </p:txBody>
@@ -27006,7 +27006,7 @@
                 </a:solidFill>
                 <a:latin typeface="Calibri"/>
               </a:rPr>
-              <a:t>What the sale cost at list price, and the Diwali hold-back offered, in two sentences.</a:t>
+              <a:t>What the exposed paid at list price, and what a Diwali hold-back costs, in two sentences.</a:t>
             </a:r>
           </a:p>
         </p:txBody>

</xml_diff>

<commit_message>
W01 D4 after the second review: notebook 5 states the dashboard's 506 words and the builder recounts them before it writes the notebook, so the cell can no longer fail once learners run chapter 3's own cells; chapter 3's sixth question asks for the flips' reading, which its routes give at 0.387 and 0.344, with "deal" as the chapter's one word; notebook 4's map labels question 6 as the deck does; morning S32's note gives Retail-Core's Rs 47,550; the second case fits its forty minutes, four on the slides and thirty-four in pairs at 6, 7, 10 and 11, with S21's note pricing the hold-back on both segments; the provenance corrects three of its own lines
Co-Authored-By: Claude Opus 5.5 <noreply@anthropic.com>
Claude-Session: https://claude.ai/code/session_01FuBiPzJ5MbkU3CtQUt4t8P
</commit_message>
<xml_diff>
--- a/content/W01/D4/slides/C2_W01_D04_half2_STUDENT.pptx
+++ b/content/W01/D4/slides/C2_W01_D04_half2_STUDENT.pptx
@@ -1929,7 +1929,12 @@
           <a:lstStyle/>
           <a:p>
             <a:r>
-              <a:t>LIVE. Ten-minute break before this chapter, then forty minutes in pairs. Pairs work from</a:t>
+              <a:t>LIVE. Ten-minute break before this chapter, then forty minutes: four on S21 and S22, thirty-four</a:t>
+            </a:r>
+          </a:p>
+          <a:p>
+            <a:r>
+              <a:t>in pairs, and two on S23a once the replies are spoken. Pairs work from</a:t>
             </a:r>
           </a:p>
           <a:p>
@@ -1939,7 +1944,7 @@
           </a:p>
           <a:p>
             <a:r>
-              <a:t>One partner plays Marketing for the last eight minutes.</a:t>
+              <a:t>One partner plays Marketing for the last six minutes of the pairs' time.</a:t>
             </a:r>
           </a:p>
         </p:txBody>
@@ -2009,17 +2014,17 @@
           <a:lstStyle/>
           <a:p>
             <a:r>
-              <a:t>LIVE, 3 minutes. Part 4 is spoken before anything is written. The partner playing Marketing is</a:t>
-            </a:r>
-          </a:p>
-          <a:p>
-            <a:r>
-              <a:t>allowed to push once more, and the pair answers with chapter 6's design and its price. Then</a:t>
-            </a:r>
-          </a:p>
-          <a:p>
-            <a:r>
-              <a:t>Marketing's rebuttal.</a:t>
+              <a:t>LIVE, 2 minutes. Part 4 is spoken before anything is written. The partner playing Marketing is</a:t>
+            </a:r>
+          </a:p>
+          <a:p>
+            <a:r>
+              <a:t>allowed to push once more, and the pair answers with chapter 6's design, priced on this list for</a:t>
+            </a:r>
+          </a:p>
+          <a:p>
+            <a:r>
+              <a:t>both segments as part 4 asks, where chapter 6 priced Retail-Plus alone. Then Marketing's rebuttal.</a:t>
             </a:r>
           </a:p>
         </p:txBody>
@@ -2089,7 +2094,7 @@
           <a:lstStyle/>
           <a:p>
             <a:r>
-              <a:t>LIVE, 3 minutes. Both numbers are in the platform's list and the pair can reproduce them. The trap is</a:t>
+              <a:t>LIVE, 2 minutes. Both numbers are in the platform's list and the pair can reproduce them. The trap is</a:t>
             </a:r>
           </a:p>
           <a:p>
@@ -2169,7 +2174,7 @@
           <a:lstStyle/>
           <a:p>
             <a:r>
-              <a:t>LIVE, 3 minutes, then the pairs work for the rest of the forty. The campaigns table records 15</a:t>
+              <a:t>LIVE, 1 minute, when the pairs reach part 4, inside its eleven minutes. The campaigns table records 15</a:t>
             </a:r>
           </a:p>
           <a:p>

</xml_diff>